<commit_message>
final Day 5 presentation
</commit_message>
<xml_diff>
--- a/presentations/Day 5 - From ML to AI-Enabled Workflows/00_introduction_from_ml_to_ai_workflows.pptx
+++ b/presentations/Day 5 - From ML to AI-Enabled Workflows/00_introduction_from_ml_to_ai_workflows.pptx
@@ -5,7 +5,7 @@
     <p:sldMasterId id="2147483648" r:id="rId1"/>
   </p:sldMasterIdLst>
   <p:notesMasterIdLst>
-    <p:notesMasterId r:id="rId11"/>
+    <p:notesMasterId r:id="rId10"/>
   </p:notesMasterIdLst>
   <p:sldIdLst>
     <p:sldId id="256" r:id="rId2"/>
@@ -16,7 +16,6 @@
     <p:sldId id="261" r:id="rId7"/>
     <p:sldId id="262" r:id="rId8"/>
     <p:sldId id="263" r:id="rId9"/>
-    <p:sldId id="264" r:id="rId10"/>
   </p:sldIdLst>
   <p:sldSz cx="12192000" cy="6858000"/>
   <p:notesSz cx="6858000" cy="12192000"/>
@@ -899,90 +898,6 @@
             <a:fld id="{F7021451-1387-4CA6-816F-3879F97B5CBC}" type="slidenum">
               <a:rPr lang="en-US"/>
               <a:t>8</a:t>
-            </a:fld>
-            <a:endParaRPr lang="en-US"/>
-          </a:p>
-        </p:txBody>
-      </p:sp>
-    </p:spTree>
-    <p:extLst>
-      <p:ext uri="{BB962C8B-B14F-4D97-AF65-F5344CB8AC3E}">
-        <p14:creationId xmlns:p14="http://schemas.microsoft.com/office/powerpoint/2010/main" val="1024086991"/>
-      </p:ext>
-    </p:extLst>
-  </p:cSld>
-  <p:clrMapOvr>
-    <a:masterClrMapping/>
-  </p:clrMapOvr>
-</p:notes>
-</file>
-
-<file path=ppt/notesSlides/notesSlide9.xml><?xml version="1.0" encoding="utf-8"?>
-<p:notes xmlns:a="http://schemas.openxmlformats.org/drawingml/2006/main" xmlns:r="http://schemas.openxmlformats.org/officeDocument/2006/relationships" xmlns:p="http://schemas.openxmlformats.org/presentationml/2006/main">
-  <p:cSld>
-    <p:spTree>
-      <p:nvGrpSpPr>
-        <p:cNvPr id="1" name=""/>
-        <p:cNvGrpSpPr/>
-        <p:nvPr/>
-      </p:nvGrpSpPr>
-      <p:grpSpPr>
-        <a:xfrm>
-          <a:off x="0" y="0"/>
-          <a:ext cx="0" cy="0"/>
-          <a:chOff x="0" y="0"/>
-          <a:chExt cx="0" cy="0"/>
-        </a:xfrm>
-      </p:grpSpPr>
-      <p:sp>
-        <p:nvSpPr>
-          <p:cNvPr id="2" name="Slide Image Placeholder 1"/>
-          <p:cNvSpPr>
-            <a:spLocks noGrp="1" noRot="1" noChangeAspect="1"/>
-          </p:cNvSpPr>
-          <p:nvPr>
-            <p:ph type="sldImg"/>
-          </p:nvPr>
-        </p:nvSpPr>
-        <p:spPr/>
-      </p:sp>
-      <p:sp>
-        <p:nvSpPr>
-          <p:cNvPr id="3" name="Notes Placeholder 2"/>
-          <p:cNvSpPr>
-            <a:spLocks noGrp="1"/>
-          </p:cNvSpPr>
-          <p:nvPr>
-            <p:ph type="body" idx="1"/>
-          </p:nvPr>
-        </p:nvSpPr>
-        <p:spPr/>
-        <p:txBody>
-          <a:bodyPr/>
-          <a:lstStyle/>
-          <a:p>
-            <a:endParaRPr lang="en-US" dirty="0"/>
-          </a:p>
-        </p:txBody>
-      </p:sp>
-      <p:sp>
-        <p:nvSpPr>
-          <p:cNvPr id="4" name="Slide Number Placeholder 3"/>
-          <p:cNvSpPr>
-            <a:spLocks noGrp="1"/>
-          </p:cNvSpPr>
-          <p:nvPr>
-            <p:ph type="sldNum" sz="quarter" idx="10"/>
-          </p:nvPr>
-        </p:nvSpPr>
-        <p:spPr/>
-        <p:txBody>
-          <a:bodyPr/>
-          <a:lstStyle/>
-          <a:p>
-            <a:fld id="{F7021451-1387-4CA6-816F-3879F97B5CBC}" type="slidenum">
-              <a:rPr lang="en-US"/>
-              <a:t>9</a:t>
             </a:fld>
             <a:endParaRPr lang="en-US"/>
           </a:p>
@@ -2159,14 +2074,14 @@
               <a:buNone/>
             </a:pPr>
             <a:r>
-              <a:rPr lang="en-US" sz="1050" dirty="0">
+              <a:rPr lang="en-US" sz="1400" dirty="0">
                 <a:solidFill>
                   <a:srgbClr val="666666"/>
                 </a:solidFill>
               </a:rPr>
               <a:t>Day 5 connects the foundational machine-learning workflow to AI-assisted implementation and interpretation.</a:t>
             </a:r>
-            <a:endParaRPr lang="en-US" sz="1050" dirty="0"/>
+            <a:endParaRPr lang="en-US" sz="1400" dirty="0"/>
           </a:p>
         </p:txBody>
       </p:sp>
@@ -2275,28 +2190,28 @@
               <a:buNone/>
             </a:pPr>
             <a:r>
-              <a:rPr lang="en-US" sz="900" b="1" dirty="0">
+              <a:rPr lang="en-US" sz="1400" b="1" dirty="0">
                 <a:solidFill>
                   <a:srgbClr val="222222"/>
                 </a:solidFill>
               </a:rPr>
               <a:t>Problem framing</a:t>
             </a:r>
-            <a:endParaRPr lang="en-US" sz="900" dirty="0"/>
+            <a:endParaRPr lang="en-US" sz="1400" dirty="0"/>
           </a:p>
           <a:p>
             <a:pPr marL="0" indent="0" algn="ctr">
               <a:buNone/>
             </a:pPr>
             <a:r>
-              <a:rPr lang="en-US" sz="900" b="1" dirty="0">
+              <a:rPr lang="en-US" sz="1400" b="1" dirty="0">
                 <a:solidFill>
                   <a:srgbClr val="222222"/>
                 </a:solidFill>
               </a:rPr>
               <a:t>Regression</a:t>
             </a:r>
-            <a:endParaRPr lang="en-US" sz="900" dirty="0"/>
+            <a:endParaRPr lang="en-US" sz="1400" dirty="0"/>
           </a:p>
         </p:txBody>
       </p:sp>
@@ -2373,28 +2288,28 @@
               <a:buNone/>
             </a:pPr>
             <a:r>
-              <a:rPr lang="en-US" sz="900" b="1" dirty="0">
+              <a:rPr lang="en-US" sz="1400" b="1" dirty="0">
                 <a:solidFill>
                   <a:srgbClr val="222222"/>
                 </a:solidFill>
               </a:rPr>
               <a:t>Classification</a:t>
             </a:r>
-            <a:endParaRPr lang="en-US" sz="900" dirty="0"/>
+            <a:endParaRPr lang="en-US" sz="1400" dirty="0"/>
           </a:p>
           <a:p>
             <a:pPr marL="0" indent="0" algn="ctr">
               <a:buNone/>
             </a:pPr>
             <a:r>
-              <a:rPr lang="en-US" sz="900" b="1" dirty="0">
+              <a:rPr lang="en-US" sz="1400" b="1" dirty="0">
                 <a:solidFill>
                   <a:srgbClr val="222222"/>
                 </a:solidFill>
               </a:rPr>
               <a:t>Data preparation</a:t>
             </a:r>
-            <a:endParaRPr lang="en-US" sz="900" dirty="0"/>
+            <a:endParaRPr lang="en-US" sz="1400" dirty="0"/>
           </a:p>
         </p:txBody>
       </p:sp>
@@ -2471,28 +2386,28 @@
               <a:buNone/>
             </a:pPr>
             <a:r>
-              <a:rPr lang="en-US" sz="900" b="1" dirty="0">
+              <a:rPr lang="en-US" sz="1400" b="1" dirty="0">
                 <a:solidFill>
                   <a:srgbClr val="222222"/>
                 </a:solidFill>
               </a:rPr>
               <a:t>AI assistance</a:t>
             </a:r>
-            <a:endParaRPr lang="en-US" sz="900" dirty="0"/>
+            <a:endParaRPr lang="en-US" sz="1400" dirty="0"/>
           </a:p>
           <a:p>
             <a:pPr marL="0" indent="0" algn="ctr">
               <a:buNone/>
             </a:pPr>
             <a:r>
-              <a:rPr lang="en-US" sz="900" b="1" dirty="0">
+              <a:rPr lang="en-US" sz="1400" b="1" dirty="0">
                 <a:solidFill>
                   <a:srgbClr val="222222"/>
                 </a:solidFill>
               </a:rPr>
               <a:t>Validated workflows</a:t>
             </a:r>
-            <a:endParaRPr lang="en-US" sz="900" dirty="0"/>
+            <a:endParaRPr lang="en-US" sz="1400" dirty="0"/>
           </a:p>
         </p:txBody>
       </p:sp>
@@ -2569,28 +2484,28 @@
               <a:buNone/>
             </a:pPr>
             <a:r>
-              <a:rPr lang="en-US" sz="900" b="1" dirty="0">
+              <a:rPr lang="en-US" sz="1400" b="1" dirty="0">
                 <a:solidFill>
                   <a:srgbClr val="222222"/>
                 </a:solidFill>
               </a:rPr>
               <a:t>Apply to teaching</a:t>
             </a:r>
-            <a:endParaRPr lang="en-US" sz="900" dirty="0"/>
+            <a:endParaRPr lang="en-US" sz="1400" dirty="0"/>
           </a:p>
           <a:p>
             <a:pPr marL="0" indent="0" algn="ctr">
               <a:buNone/>
             </a:pPr>
             <a:r>
-              <a:rPr lang="en-US" sz="900" b="1" dirty="0">
+              <a:rPr lang="en-US" sz="1400" b="1" dirty="0">
                 <a:solidFill>
                   <a:srgbClr val="222222"/>
                 </a:solidFill>
               </a:rPr>
               <a:t>research workflows</a:t>
             </a:r>
-            <a:endParaRPr lang="en-US" sz="900" dirty="0"/>
+            <a:endParaRPr lang="en-US" sz="1400" dirty="0"/>
           </a:p>
         </p:txBody>
       </p:sp>
@@ -2693,14 +2608,14 @@
               <a:buNone/>
             </a:pPr>
             <a:r>
-              <a:rPr lang="en-US" sz="1050" b="1" dirty="0">
+              <a:rPr lang="en-US" sz="2000" b="1" dirty="0">
                 <a:solidFill>
                   <a:srgbClr val="CC0000"/>
                 </a:solidFill>
               </a:rPr>
               <a:t>Key shift: the LLM does not create new evidence; it helps organize, explain, and implement evidence that faculty can validate.</a:t>
             </a:r>
-            <a:endParaRPr lang="en-US" sz="1050" dirty="0"/>
+            <a:endParaRPr lang="en-US" sz="2000" dirty="0"/>
           </a:p>
         </p:txBody>
       </p:sp>
@@ -2773,6 +2688,36 @@
           <a:chExt cx="0" cy="0"/>
         </a:xfrm>
       </p:grpSpPr>
+      <p:pic>
+        <p:nvPicPr>
+          <p:cNvPr id="29" name="Picture 28">
+            <a:extLst>
+              <a:ext uri="{FF2B5EF4-FFF2-40B4-BE49-F238E27FC236}">
+                <a16:creationId xmlns:a16="http://schemas.microsoft.com/office/drawing/2014/main" id="{F7FDA8DF-8B58-77D4-B287-88B7E052837E}"/>
+              </a:ext>
+            </a:extLst>
+          </p:cNvPr>
+          <p:cNvPicPr>
+            <a:picLocks noChangeAspect="1"/>
+          </p:cNvPicPr>
+          <p:nvPr/>
+        </p:nvPicPr>
+        <p:blipFill>
+          <a:blip r:embed="rId3"/>
+          <a:stretch>
+            <a:fillRect/>
+          </a:stretch>
+        </p:blipFill>
+        <p:spPr>
+          <a:xfrm>
+            <a:off x="3099816" y="2860934"/>
+            <a:ext cx="5655199" cy="3182741"/>
+          </a:xfrm>
+          <a:prstGeom prst="rect">
+            <a:avLst/>
+          </a:prstGeom>
+        </p:spPr>
+      </p:pic>
       <p:sp>
         <p:nvSpPr>
           <p:cNvPr id="2" name="Shape 0"/>
@@ -2949,14 +2894,14 @@
               <a:buNone/>
             </a:pPr>
             <a:r>
-              <a:rPr lang="en-US" sz="1050" dirty="0">
+              <a:rPr lang="en-US" sz="1400" dirty="0">
                 <a:solidFill>
                   <a:srgbClr val="666666"/>
                 </a:solidFill>
               </a:rPr>
               <a:t>Day 3 established the vocabulary and structure needed to create defensible ML problems.</a:t>
             </a:r>
-            <a:endParaRPr lang="en-US" sz="1050" dirty="0"/>
+            <a:endParaRPr lang="en-US" sz="1400" dirty="0"/>
           </a:p>
         </p:txBody>
       </p:sp>
@@ -3085,7 +3030,7 @@
         </p:spPr>
         <p:txBody>
           <a:bodyPr wrap="square" lIns="254" tIns="254" rIns="254" bIns="254" rtlCol="0" anchor="ctr">
-            <a:normAutofit/>
+            <a:noAutofit/>
           </a:bodyPr>
           <a:lstStyle/>
           <a:p>
@@ -3093,56 +3038,56 @@
               <a:buNone/>
             </a:pPr>
             <a:r>
-              <a:rPr lang="en-US" sz="720" dirty="0">
+              <a:rPr lang="en-US" sz="1200" dirty="0">
                 <a:solidFill>
                   <a:srgbClr val="222222"/>
                 </a:solidFill>
               </a:rPr>
               <a:t>Prediction objective</a:t>
             </a:r>
-            <a:endParaRPr lang="en-US" sz="720" dirty="0"/>
-          </a:p>
-          <a:p>
-            <a:pPr marL="0" indent="0">
-              <a:buNone/>
-            </a:pPr>
-            <a:r>
-              <a:rPr lang="en-US" sz="720" dirty="0">
+            <a:endParaRPr lang="en-US" sz="1200" dirty="0"/>
+          </a:p>
+          <a:p>
+            <a:pPr marL="0" indent="0">
+              <a:buNone/>
+            </a:pPr>
+            <a:r>
+              <a:rPr lang="en-US" sz="1200" dirty="0">
                 <a:solidFill>
                   <a:srgbClr val="222222"/>
                 </a:solidFill>
               </a:rPr>
               <a:t>Inputs and outputs</a:t>
             </a:r>
-            <a:endParaRPr lang="en-US" sz="720" dirty="0"/>
-          </a:p>
-          <a:p>
-            <a:pPr marL="0" indent="0">
-              <a:buNone/>
-            </a:pPr>
-            <a:r>
-              <a:rPr lang="en-US" sz="720" dirty="0">
+            <a:endParaRPr lang="en-US" sz="1200" dirty="0"/>
+          </a:p>
+          <a:p>
+            <a:pPr marL="0" indent="0">
+              <a:buNone/>
+            </a:pPr>
+            <a:r>
+              <a:rPr lang="en-US" sz="1200" dirty="0">
                 <a:solidFill>
                   <a:srgbClr val="222222"/>
                 </a:solidFill>
               </a:rPr>
               <a:t>Unit of observation</a:t>
             </a:r>
-            <a:endParaRPr lang="en-US" sz="720" dirty="0"/>
-          </a:p>
-          <a:p>
-            <a:pPr marL="0" indent="0">
-              <a:buNone/>
-            </a:pPr>
-            <a:r>
-              <a:rPr lang="en-US" sz="720" dirty="0">
+            <a:endParaRPr lang="en-US" sz="1200" dirty="0"/>
+          </a:p>
+          <a:p>
+            <a:pPr marL="0" indent="0">
+              <a:buNone/>
+            </a:pPr>
+            <a:r>
+              <a:rPr lang="en-US" sz="1200" dirty="0">
                 <a:solidFill>
                   <a:srgbClr val="222222"/>
                 </a:solidFill>
               </a:rPr>
               <a:t>Target variable</a:t>
             </a:r>
-            <a:endParaRPr lang="en-US" sz="720" dirty="0"/>
+            <a:endParaRPr lang="en-US" sz="1200" dirty="0"/>
           </a:p>
         </p:txBody>
       </p:sp>
@@ -3239,7 +3184,7 @@
         </p:spPr>
         <p:txBody>
           <a:bodyPr wrap="square" lIns="254" tIns="254" rIns="254" bIns="254" rtlCol="0" anchor="ctr">
-            <a:normAutofit/>
+            <a:noAutofit/>
           </a:bodyPr>
           <a:lstStyle/>
           <a:p>
@@ -3247,70 +3192,70 @@
               <a:buNone/>
             </a:pPr>
             <a:r>
-              <a:rPr lang="en-US" sz="720" dirty="0">
+              <a:rPr lang="en-US" sz="1000" dirty="0">
                 <a:solidFill>
                   <a:srgbClr val="222222"/>
                 </a:solidFill>
               </a:rPr>
               <a:t>Regression</a:t>
             </a:r>
-            <a:endParaRPr lang="en-US" sz="720" dirty="0"/>
-          </a:p>
-          <a:p>
-            <a:pPr marL="0" indent="0">
-              <a:buNone/>
-            </a:pPr>
-            <a:r>
-              <a:rPr lang="en-US" sz="720" dirty="0">
+            <a:endParaRPr lang="en-US" sz="1000" dirty="0"/>
+          </a:p>
+          <a:p>
+            <a:pPr marL="0" indent="0">
+              <a:buNone/>
+            </a:pPr>
+            <a:r>
+              <a:rPr lang="en-US" sz="1000" dirty="0">
                 <a:solidFill>
                   <a:srgbClr val="222222"/>
                 </a:solidFill>
               </a:rPr>
               <a:t>Classification</a:t>
             </a:r>
-            <a:endParaRPr lang="en-US" sz="720" dirty="0"/>
-          </a:p>
-          <a:p>
-            <a:pPr marL="0" indent="0">
-              <a:buNone/>
-            </a:pPr>
-            <a:r>
-              <a:rPr lang="en-US" sz="720" dirty="0">
+            <a:endParaRPr lang="en-US" sz="1000" dirty="0"/>
+          </a:p>
+          <a:p>
+            <a:pPr marL="0" indent="0">
+              <a:buNone/>
+            </a:pPr>
+            <a:r>
+              <a:rPr lang="en-US" sz="1000" dirty="0">
                 <a:solidFill>
                   <a:srgbClr val="222222"/>
                 </a:solidFill>
               </a:rPr>
               <a:t>Clustering</a:t>
             </a:r>
-            <a:endParaRPr lang="en-US" sz="720" dirty="0"/>
-          </a:p>
-          <a:p>
-            <a:pPr marL="0" indent="0">
-              <a:buNone/>
-            </a:pPr>
-            <a:r>
-              <a:rPr lang="en-US" sz="720" dirty="0">
+            <a:endParaRPr lang="en-US" sz="1000" dirty="0"/>
+          </a:p>
+          <a:p>
+            <a:pPr marL="0" indent="0">
+              <a:buNone/>
+            </a:pPr>
+            <a:r>
+              <a:rPr lang="en-US" sz="1000" dirty="0">
                 <a:solidFill>
                   <a:srgbClr val="222222"/>
                 </a:solidFill>
               </a:rPr>
               <a:t>Forecasting</a:t>
             </a:r>
-            <a:endParaRPr lang="en-US" sz="720" dirty="0"/>
-          </a:p>
-          <a:p>
-            <a:pPr marL="0" indent="0">
-              <a:buNone/>
-            </a:pPr>
-            <a:r>
-              <a:rPr lang="en-US" sz="720" dirty="0">
+            <a:endParaRPr lang="en-US" sz="1000" dirty="0"/>
+          </a:p>
+          <a:p>
+            <a:pPr marL="0" indent="0">
+              <a:buNone/>
+            </a:pPr>
+            <a:r>
+              <a:rPr lang="en-US" sz="1000" dirty="0">
                 <a:solidFill>
                   <a:srgbClr val="222222"/>
                 </a:solidFill>
               </a:rPr>
               <a:t>Anomaly detection</a:t>
             </a:r>
-            <a:endParaRPr lang="en-US" sz="720" dirty="0"/>
+            <a:endParaRPr lang="en-US" sz="1000" dirty="0"/>
           </a:p>
         </p:txBody>
       </p:sp>
@@ -3407,7 +3352,7 @@
         </p:spPr>
         <p:txBody>
           <a:bodyPr wrap="square" lIns="254" tIns="254" rIns="254" bIns="254" rtlCol="0" anchor="ctr">
-            <a:normAutofit/>
+            <a:noAutofit/>
           </a:bodyPr>
           <a:lstStyle/>
           <a:p>
@@ -3415,56 +3360,56 @@
               <a:buNone/>
             </a:pPr>
             <a:r>
-              <a:rPr lang="en-US" sz="720" dirty="0">
+              <a:rPr lang="en-US" sz="1200" dirty="0">
                 <a:solidFill>
                   <a:srgbClr val="222222"/>
                 </a:solidFill>
               </a:rPr>
               <a:t>Linear models</a:t>
             </a:r>
-            <a:endParaRPr lang="en-US" sz="720" dirty="0"/>
-          </a:p>
-          <a:p>
-            <a:pPr marL="0" indent="0">
-              <a:buNone/>
-            </a:pPr>
-            <a:r>
-              <a:rPr lang="en-US" sz="720" dirty="0">
+            <a:endParaRPr lang="en-US" sz="1200" dirty="0"/>
+          </a:p>
+          <a:p>
+            <a:pPr marL="0" indent="0">
+              <a:buNone/>
+            </a:pPr>
+            <a:r>
+              <a:rPr lang="en-US" sz="1200" dirty="0">
                 <a:solidFill>
                   <a:srgbClr val="222222"/>
                 </a:solidFill>
               </a:rPr>
               <a:t>Polynomial trends</a:t>
             </a:r>
-            <a:endParaRPr lang="en-US" sz="720" dirty="0"/>
-          </a:p>
-          <a:p>
-            <a:pPr marL="0" indent="0">
-              <a:buNone/>
-            </a:pPr>
-            <a:r>
-              <a:rPr lang="en-US" sz="720" dirty="0">
+            <a:endParaRPr lang="en-US" sz="1200" dirty="0"/>
+          </a:p>
+          <a:p>
+            <a:pPr marL="0" indent="0">
+              <a:buNone/>
+            </a:pPr>
+            <a:r>
+              <a:rPr lang="en-US" sz="1200" dirty="0">
                 <a:solidFill>
                   <a:srgbClr val="222222"/>
                 </a:solidFill>
               </a:rPr>
               <a:t>Regularization</a:t>
             </a:r>
-            <a:endParaRPr lang="en-US" sz="720" dirty="0"/>
-          </a:p>
-          <a:p>
-            <a:pPr marL="0" indent="0">
-              <a:buNone/>
-            </a:pPr>
-            <a:r>
-              <a:rPr lang="en-US" sz="720" dirty="0">
+            <a:endParaRPr lang="en-US" sz="1200" dirty="0"/>
+          </a:p>
+          <a:p>
+            <a:pPr marL="0" indent="0">
+              <a:buNone/>
+            </a:pPr>
+            <a:r>
+              <a:rPr lang="en-US" sz="1200" dirty="0">
                 <a:solidFill>
                   <a:srgbClr val="222222"/>
                 </a:solidFill>
               </a:rPr>
               <a:t>Residuals and MAE/RMSE</a:t>
             </a:r>
-            <a:endParaRPr lang="en-US" sz="720" dirty="0"/>
+            <a:endParaRPr lang="en-US" sz="1200" dirty="0"/>
           </a:p>
         </p:txBody>
       </p:sp>
@@ -3561,7 +3506,7 @@
         </p:spPr>
         <p:txBody>
           <a:bodyPr wrap="square" lIns="254" tIns="254" rIns="254" bIns="254" rtlCol="0" anchor="ctr">
-            <a:normAutofit/>
+            <a:noAutofit/>
           </a:bodyPr>
           <a:lstStyle/>
           <a:p>
@@ -3569,42 +3514,42 @@
               <a:buNone/>
             </a:pPr>
             <a:r>
-              <a:rPr lang="en-US" sz="720" dirty="0">
+              <a:rPr lang="en-US" sz="1200" dirty="0">
                 <a:solidFill>
                   <a:srgbClr val="222222"/>
                 </a:solidFill>
               </a:rPr>
               <a:t>Mean or majority baseline</a:t>
             </a:r>
-            <a:endParaRPr lang="en-US" sz="720" dirty="0"/>
-          </a:p>
-          <a:p>
-            <a:pPr marL="0" indent="0">
-              <a:buNone/>
-            </a:pPr>
-            <a:r>
-              <a:rPr lang="en-US" sz="720" dirty="0">
+            <a:endParaRPr lang="en-US" sz="1200" dirty="0"/>
+          </a:p>
+          <a:p>
+            <a:pPr marL="0" indent="0">
+              <a:buNone/>
+            </a:pPr>
+            <a:r>
+              <a:rPr lang="en-US" sz="1200" dirty="0">
                 <a:solidFill>
                   <a:srgbClr val="222222"/>
                 </a:solidFill>
               </a:rPr>
               <a:t>Metric selection</a:t>
             </a:r>
-            <a:endParaRPr lang="en-US" sz="720" dirty="0"/>
-          </a:p>
-          <a:p>
-            <a:pPr marL="0" indent="0">
-              <a:buNone/>
-            </a:pPr>
-            <a:r>
-              <a:rPr lang="en-US" sz="720" dirty="0">
+            <a:endParaRPr lang="en-US" sz="1200" dirty="0"/>
+          </a:p>
+          <a:p>
+            <a:pPr marL="0" indent="0">
+              <a:buNone/>
+            </a:pPr>
+            <a:r>
+              <a:rPr lang="en-US" sz="1200" dirty="0">
                 <a:solidFill>
                   <a:srgbClr val="222222"/>
                 </a:solidFill>
               </a:rPr>
               <a:t>Practical success criteria</a:t>
             </a:r>
-            <a:endParaRPr lang="en-US" sz="720" dirty="0"/>
+            <a:endParaRPr lang="en-US" sz="1200" dirty="0"/>
           </a:p>
         </p:txBody>
       </p:sp>
@@ -3701,7 +3646,7 @@
         </p:spPr>
         <p:txBody>
           <a:bodyPr wrap="square" lIns="254" tIns="254" rIns="254" bIns="254" rtlCol="0" anchor="ctr">
-            <a:normAutofit/>
+            <a:noAutofit/>
           </a:bodyPr>
           <a:lstStyle/>
           <a:p>
@@ -3709,14 +3654,14 @@
               <a:buNone/>
             </a:pPr>
             <a:r>
-              <a:rPr lang="en-US" sz="720" dirty="0">
+              <a:rPr lang="en-US" sz="1200" dirty="0">
                 <a:solidFill>
                   <a:srgbClr val="222222"/>
                 </a:solidFill>
               </a:rPr>
               <a:t>A framed ML problem with inputs, target, baseline, and metric.</a:t>
             </a:r>
-            <a:endParaRPr lang="en-US" sz="720" dirty="0"/>
+            <a:endParaRPr lang="en-US" sz="1200" dirty="0"/>
           </a:p>
         </p:txBody>
       </p:sp>
@@ -3728,7 +3673,7 @@
         </p:nvSpPr>
         <p:spPr>
           <a:xfrm>
-            <a:off x="594360" y="3840480"/>
+            <a:off x="731520" y="5916168"/>
             <a:ext cx="2286000" cy="228600"/>
           </a:xfrm>
           <a:prstGeom prst="rect">
@@ -3745,14 +3690,14 @@
               <a:buNone/>
             </a:pPr>
             <a:r>
-              <a:rPr lang="en-US" sz="800" b="1" dirty="0">
+              <a:rPr lang="en-US" sz="1200" b="1" dirty="0">
                 <a:solidFill>
                   <a:srgbClr val="CC0000"/>
                 </a:solidFill>
               </a:rPr>
               <a:t>What carries forward to Day 5?</a:t>
             </a:r>
-            <a:endParaRPr lang="en-US" sz="800" dirty="0"/>
+            <a:endParaRPr lang="en-US" sz="1200" dirty="0"/>
           </a:p>
         </p:txBody>
       </p:sp>
@@ -3764,7 +3709,7 @@
         </p:nvSpPr>
         <p:spPr>
           <a:xfrm>
-            <a:off x="822960" y="4224528"/>
+            <a:off x="649224" y="5892799"/>
             <a:ext cx="10881360" cy="1005840"/>
           </a:xfrm>
           <a:prstGeom prst="rect">
@@ -3783,7 +3728,7 @@
               <a:buNone/>
             </a:pPr>
             <a:r>
-              <a:rPr lang="en-US" sz="1000" dirty="0">
+              <a:rPr lang="en-US" sz="1200" dirty="0">
                 <a:solidFill>
                   <a:srgbClr val="222222"/>
                 </a:solidFill>
@@ -3792,7 +3737,7 @@
 • Baselines and metrics become the evidence that an AI explanation must respect.
 • LLM-generated conclusions must be checked against the original ML framing.</a:t>
             </a:r>
-            <a:endParaRPr lang="en-US" sz="1000" dirty="0"/>
+            <a:endParaRPr lang="en-US" sz="1200" dirty="0"/>
           </a:p>
         </p:txBody>
       </p:sp>
@@ -4211,7 +4156,7 @@
         </p:spPr>
         <p:txBody>
           <a:bodyPr wrap="square" lIns="254" tIns="254" rIns="254" bIns="254" rtlCol="0" anchor="ctr">
-            <a:normAutofit/>
+            <a:noAutofit/>
           </a:bodyPr>
           <a:lstStyle/>
           <a:p>
@@ -4219,14 +4164,14 @@
               <a:buNone/>
             </a:pPr>
             <a:r>
-              <a:rPr lang="en-US" sz="1000" dirty="0">
+              <a:rPr lang="en-US" sz="1200" dirty="0">
                 <a:solidFill>
                   <a:srgbClr val="222222"/>
                 </a:solidFill>
               </a:rPr>
               <a:t>Predicted categorical outcomes using logistic regression, decision trees, probabilities, thresholds, and confusion matrices.</a:t>
             </a:r>
-            <a:endParaRPr lang="en-US" sz="1000" dirty="0"/>
+            <a:endParaRPr lang="en-US" sz="1200" dirty="0"/>
           </a:p>
         </p:txBody>
       </p:sp>
@@ -4260,7 +4205,7 @@
           <a:bodyPr/>
           <a:lstStyle/>
           <a:p>
-            <a:endParaRPr lang="en-US"/>
+            <a:endParaRPr lang="en-US" dirty="0"/>
           </a:p>
         </p:txBody>
       </p:sp>
@@ -4357,7 +4302,7 @@
         </p:spPr>
         <p:txBody>
           <a:bodyPr wrap="square" lIns="254" tIns="254" rIns="254" bIns="254" rtlCol="0" anchor="ctr">
-            <a:normAutofit/>
+            <a:noAutofit/>
           </a:bodyPr>
           <a:lstStyle/>
           <a:p>
@@ -4365,14 +4310,14 @@
               <a:buNone/>
             </a:pPr>
             <a:r>
-              <a:rPr lang="en-US" sz="1000" dirty="0">
+              <a:rPr lang="en-US" sz="1200" dirty="0">
                 <a:solidFill>
                   <a:srgbClr val="222222"/>
                 </a:solidFill>
               </a:rPr>
               <a:t>Built a first-pass model workflow with data inspection, baselines, simple models, metrics, and interpretation.</a:t>
             </a:r>
-            <a:endParaRPr lang="en-US" sz="1000" dirty="0"/>
+            <a:endParaRPr lang="en-US" sz="1200" dirty="0"/>
           </a:p>
         </p:txBody>
       </p:sp>
@@ -4503,7 +4448,7 @@
         </p:spPr>
         <p:txBody>
           <a:bodyPr wrap="square" lIns="254" tIns="254" rIns="254" bIns="254" rtlCol="0" anchor="ctr">
-            <a:normAutofit/>
+            <a:noAutofit/>
           </a:bodyPr>
           <a:lstStyle/>
           <a:p>
@@ -4511,14 +4456,14 @@
               <a:buNone/>
             </a:pPr>
             <a:r>
-              <a:rPr lang="en-US" sz="1000" dirty="0">
+              <a:rPr lang="en-US" sz="1200" dirty="0">
                 <a:solidFill>
                   <a:srgbClr val="222222"/>
                 </a:solidFill>
               </a:rPr>
               <a:t>Addressed missing values, outliers, data types, encoding, scaling, leakage, and domain-informed features.</a:t>
             </a:r>
-            <a:endParaRPr lang="en-US" sz="1000" dirty="0"/>
+            <a:endParaRPr lang="en-US" sz="1200" dirty="0"/>
           </a:p>
         </p:txBody>
       </p:sp>
@@ -4748,7 +4693,7 @@
         </p:nvSpPr>
         <p:spPr>
           <a:xfrm>
-            <a:off x="1289304" y="4690872"/>
+            <a:off x="1289304" y="4576572"/>
             <a:ext cx="1947672" cy="228600"/>
           </a:xfrm>
           <a:prstGeom prst="rect">
@@ -4786,8 +4731,8 @@
         </p:nvSpPr>
         <p:spPr>
           <a:xfrm>
-            <a:off x="1289304" y="4983480"/>
-            <a:ext cx="1947672" cy="45720"/>
+            <a:off x="1289304" y="4892040"/>
+            <a:ext cx="2093976" cy="54864"/>
           </a:xfrm>
           <a:prstGeom prst="rect">
             <a:avLst/>
@@ -4805,14 +4750,14 @@
               <a:buNone/>
             </a:pPr>
             <a:r>
-              <a:rPr lang="en-US" sz="1000" dirty="0">
+              <a:rPr lang="en-US" sz="1200" dirty="0">
                 <a:solidFill>
                   <a:srgbClr val="222222"/>
                 </a:solidFill>
               </a:rPr>
               <a:t>accuracy • recall • F1 • silhouette</a:t>
             </a:r>
-            <a:endParaRPr lang="en-US" sz="1000" dirty="0"/>
+            <a:endParaRPr lang="en-US" sz="1200" dirty="0"/>
           </a:p>
         </p:txBody>
       </p:sp>
@@ -4860,7 +4805,7 @@
         </p:nvSpPr>
         <p:spPr>
           <a:xfrm>
-            <a:off x="3803904" y="4690872"/>
+            <a:off x="3794760" y="4615942"/>
             <a:ext cx="1947672" cy="228600"/>
           </a:xfrm>
           <a:prstGeom prst="rect">
@@ -4898,7 +4843,7 @@
         </p:nvSpPr>
         <p:spPr>
           <a:xfrm>
-            <a:off x="3803904" y="4983480"/>
+            <a:off x="3803904" y="4928616"/>
             <a:ext cx="1947672" cy="54864"/>
           </a:xfrm>
           <a:prstGeom prst="rect">
@@ -4917,14 +4862,14 @@
               <a:buNone/>
             </a:pPr>
             <a:r>
-              <a:rPr lang="en-US" sz="1000" dirty="0">
+              <a:rPr lang="en-US" sz="1200" dirty="0">
                 <a:solidFill>
                   <a:srgbClr val="222222"/>
                 </a:solidFill>
               </a:rPr>
               <a:t>confusion matrices • PCA plots</a:t>
             </a:r>
-            <a:endParaRPr lang="en-US" sz="1000" dirty="0"/>
+            <a:endParaRPr lang="en-US" sz="1200" dirty="0"/>
           </a:p>
         </p:txBody>
       </p:sp>
@@ -4972,7 +4917,7 @@
         </p:nvSpPr>
         <p:spPr>
           <a:xfrm>
-            <a:off x="6318504" y="4690872"/>
+            <a:off x="6318504" y="4615942"/>
             <a:ext cx="1947672" cy="228600"/>
           </a:xfrm>
           <a:prstGeom prst="rect">
@@ -5010,7 +4955,7 @@
         </p:nvSpPr>
         <p:spPr>
           <a:xfrm>
-            <a:off x="6318504" y="4983480"/>
+            <a:off x="6318504" y="4919472"/>
             <a:ext cx="1947672" cy="45720"/>
           </a:xfrm>
           <a:prstGeom prst="rect">
@@ -5029,14 +4974,14 @@
               <a:buNone/>
             </a:pPr>
             <a:r>
-              <a:rPr lang="en-US" sz="1000" dirty="0">
+              <a:rPr lang="en-US" sz="1200" dirty="0">
                 <a:solidFill>
                   <a:srgbClr val="222222"/>
                 </a:solidFill>
               </a:rPr>
               <a:t>features • leakage • thresholds</a:t>
             </a:r>
-            <a:endParaRPr lang="en-US" sz="1000" dirty="0"/>
+            <a:endParaRPr lang="en-US" sz="1200" dirty="0"/>
           </a:p>
         </p:txBody>
       </p:sp>
@@ -5084,7 +5029,7 @@
         </p:nvSpPr>
         <p:spPr>
           <a:xfrm>
-            <a:off x="8833104" y="4690872"/>
+            <a:off x="8833104" y="4615942"/>
             <a:ext cx="1947672" cy="228600"/>
           </a:xfrm>
           <a:prstGeom prst="rect">
@@ -5122,7 +5067,7 @@
         </p:nvSpPr>
         <p:spPr>
           <a:xfrm>
-            <a:off x="8833104" y="4983480"/>
+            <a:off x="8833104" y="4965192"/>
             <a:ext cx="1947672" cy="45720"/>
           </a:xfrm>
           <a:prstGeom prst="rect">
@@ -5141,14 +5086,14 @@
               <a:buNone/>
             </a:pPr>
             <a:r>
-              <a:rPr lang="en-US" sz="1000" dirty="0">
+              <a:rPr lang="en-US" sz="1200" dirty="0">
                 <a:solidFill>
                   <a:srgbClr val="222222"/>
                 </a:solidFill>
               </a:rPr>
               <a:t>data quality • validation • claims</a:t>
             </a:r>
-            <a:endParaRPr lang="en-US" sz="1000" dirty="0"/>
+            <a:endParaRPr lang="en-US" sz="1200" dirty="0"/>
           </a:p>
         </p:txBody>
       </p:sp>
@@ -6139,7 +6084,7 @@
         </p:spPr>
         <p:txBody>
           <a:bodyPr wrap="square" lIns="254" tIns="254" rIns="254" bIns="254" rtlCol="0" anchor="ctr">
-            <a:normAutofit/>
+            <a:noAutofit/>
           </a:bodyPr>
           <a:lstStyle/>
           <a:p>
@@ -6147,14 +6092,14 @@
               <a:buNone/>
             </a:pPr>
             <a:r>
-              <a:rPr lang="en-US" sz="1000" dirty="0">
+              <a:rPr lang="en-US" sz="1200" dirty="0">
                 <a:solidFill>
                   <a:srgbClr val="222222"/>
                 </a:solidFill>
               </a:rPr>
               <a:t>“Can AI explain this?”</a:t>
             </a:r>
-            <a:endParaRPr lang="en-US" sz="1000" dirty="0"/>
+            <a:endParaRPr lang="en-US" sz="1200" dirty="0"/>
           </a:p>
         </p:txBody>
       </p:sp>
@@ -6251,7 +6196,7 @@
         </p:spPr>
         <p:txBody>
           <a:bodyPr wrap="square" lIns="254" tIns="254" rIns="254" bIns="254" rtlCol="0" anchor="ctr">
-            <a:normAutofit/>
+            <a:noAutofit/>
           </a:bodyPr>
           <a:lstStyle/>
           <a:p>
@@ -6259,14 +6204,14 @@
               <a:buNone/>
             </a:pPr>
             <a:r>
-              <a:rPr lang="en-US" sz="1000" dirty="0">
+              <a:rPr lang="en-US" sz="1200" dirty="0">
                 <a:solidFill>
                   <a:srgbClr val="222222"/>
                 </a:solidFill>
               </a:rPr>
               <a:t>“What evidence can AI use, and what must it not claim?”</a:t>
             </a:r>
-            <a:endParaRPr lang="en-US" sz="1000" dirty="0"/>
+            <a:endParaRPr lang="en-US" sz="1200" dirty="0"/>
           </a:p>
         </p:txBody>
       </p:sp>
@@ -9973,1002 +9918,6 @@
                 </a:solidFill>
               </a:rPr>
               <a:t>8</a:t>
-            </a:r>
-            <a:endParaRPr lang="en-US" sz="550" dirty="0"/>
-          </a:p>
-        </p:txBody>
-      </p:sp>
-    </p:spTree>
-  </p:cSld>
-  <p:clrMapOvr>
-    <a:masterClrMapping/>
-  </p:clrMapOvr>
-</p:sld>
-</file>
-
-<file path=ppt/slides/slide9.xml><?xml version="1.0" encoding="utf-8"?>
-<p:sld xmlns:a="http://schemas.openxmlformats.org/drawingml/2006/main" xmlns:r="http://schemas.openxmlformats.org/officeDocument/2006/relationships" xmlns:p="http://schemas.openxmlformats.org/presentationml/2006/main">
-  <p:cSld name="Slide 9">
-    <p:bg>
-      <p:bgPr>
-        <a:solidFill>
-          <a:srgbClr val="FFFFFF"/>
-        </a:solidFill>
-        <a:effectLst/>
-      </p:bgPr>
-    </p:bg>
-    <p:spTree>
-      <p:nvGrpSpPr>
-        <p:cNvPr id="1" name=""/>
-        <p:cNvGrpSpPr/>
-        <p:nvPr/>
-      </p:nvGrpSpPr>
-      <p:grpSpPr>
-        <a:xfrm>
-          <a:off x="0" y="0"/>
-          <a:ext cx="0" cy="0"/>
-          <a:chOff x="0" y="0"/>
-          <a:chExt cx="0" cy="0"/>
-        </a:xfrm>
-      </p:grpSpPr>
-      <p:sp>
-        <p:nvSpPr>
-          <p:cNvPr id="2" name="Shape 0"/>
-          <p:cNvSpPr/>
-          <p:nvPr/>
-        </p:nvSpPr>
-        <p:spPr>
-          <a:xfrm>
-            <a:off x="0" y="118872"/>
-            <a:ext cx="12191695" cy="82296"/>
-          </a:xfrm>
-          <a:prstGeom prst="rect">
-            <a:avLst/>
-          </a:prstGeom>
-          <a:solidFill>
-            <a:srgbClr val="CC0000"/>
-          </a:solidFill>
-          <a:ln w="12700">
-            <a:solidFill>
-              <a:srgbClr val="CC0000"/>
-            </a:solidFill>
-            <a:prstDash val="solid"/>
-          </a:ln>
-        </p:spPr>
-        <p:txBody>
-          <a:bodyPr/>
-          <a:lstStyle/>
-          <a:p>
-            <a:endParaRPr lang="en-US"/>
-          </a:p>
-        </p:txBody>
-      </p:sp>
-      <p:sp>
-        <p:nvSpPr>
-          <p:cNvPr id="3" name="Text 1"/>
-          <p:cNvSpPr/>
-          <p:nvPr/>
-        </p:nvSpPr>
-        <p:spPr>
-          <a:xfrm>
-            <a:off x="256032" y="347472"/>
-            <a:ext cx="3200400" cy="182880"/>
-          </a:xfrm>
-          <a:prstGeom prst="rect">
-            <a:avLst/>
-          </a:prstGeom>
-          <a:noFill/>
-          <a:ln/>
-        </p:spPr>
-        <p:txBody>
-          <a:bodyPr wrap="square" lIns="0" tIns="0" rIns="0" bIns="0" rtlCol="0" anchor="ctr"/>
-          <a:lstStyle/>
-          <a:p>
-            <a:pPr marL="0" indent="0">
-              <a:buNone/>
-            </a:pPr>
-            <a:r>
-              <a:rPr lang="en-US" sz="1000" b="1" dirty="0">
-                <a:solidFill>
-                  <a:srgbClr val="666666"/>
-                </a:solidFill>
-                <a:latin typeface="Aptos" pitchFamily="34" charset="0"/>
-                <a:ea typeface="Aptos" pitchFamily="34" charset="-122"/>
-                <a:cs typeface="Aptos" pitchFamily="34" charset="-120"/>
-              </a:rPr>
-              <a:t>APPLIED AI DESIGN WORKSHOP</a:t>
-            </a:r>
-            <a:endParaRPr lang="en-US" sz="1000" dirty="0"/>
-          </a:p>
-        </p:txBody>
-      </p:sp>
-      <p:sp>
-        <p:nvSpPr>
-          <p:cNvPr id="4" name="Text 2"/>
-          <p:cNvSpPr/>
-          <p:nvPr/>
-        </p:nvSpPr>
-        <p:spPr>
-          <a:xfrm>
-            <a:off x="11292840" y="347472"/>
-            <a:ext cx="640080" cy="182880"/>
-          </a:xfrm>
-          <a:prstGeom prst="rect">
-            <a:avLst/>
-          </a:prstGeom>
-          <a:noFill/>
-          <a:ln/>
-        </p:spPr>
-        <p:txBody>
-          <a:bodyPr wrap="square" lIns="0" tIns="0" rIns="0" bIns="0" rtlCol="0" anchor="ctr"/>
-          <a:lstStyle/>
-          <a:p>
-            <a:pPr marL="0" indent="0" algn="r">
-              <a:buNone/>
-            </a:pPr>
-            <a:r>
-              <a:rPr lang="en-US" sz="1000" dirty="0">
-                <a:solidFill>
-                  <a:srgbClr val="666666"/>
-                </a:solidFill>
-                <a:latin typeface="Aptos" pitchFamily="34" charset="0"/>
-                <a:ea typeface="Aptos" pitchFamily="34" charset="-122"/>
-                <a:cs typeface="Aptos" pitchFamily="34" charset="-120"/>
-              </a:rPr>
-              <a:t>DAY 5</a:t>
-            </a:r>
-            <a:endParaRPr lang="en-US" sz="1000" dirty="0"/>
-          </a:p>
-        </p:txBody>
-      </p:sp>
-      <p:sp>
-        <p:nvSpPr>
-          <p:cNvPr id="5" name="Text 3"/>
-          <p:cNvSpPr/>
-          <p:nvPr/>
-        </p:nvSpPr>
-        <p:spPr>
-          <a:xfrm>
-            <a:off x="411480" y="713232"/>
-            <a:ext cx="11155680" cy="411480"/>
-          </a:xfrm>
-          <a:prstGeom prst="rect">
-            <a:avLst/>
-          </a:prstGeom>
-          <a:noFill/>
-          <a:ln/>
-        </p:spPr>
-        <p:txBody>
-          <a:bodyPr wrap="square" lIns="0" tIns="0" rIns="0" bIns="0" rtlCol="0" anchor="ctr"/>
-          <a:lstStyle/>
-          <a:p>
-            <a:pPr marL="0" indent="0">
-              <a:buNone/>
-            </a:pPr>
-            <a:r>
-              <a:rPr lang="en-US" sz="2100" b="1" dirty="0">
-                <a:solidFill>
-                  <a:srgbClr val="222222"/>
-                </a:solidFill>
-                <a:latin typeface="Aptos Display" pitchFamily="34" charset="0"/>
-                <a:ea typeface="Aptos Display" pitchFamily="34" charset="-122"/>
-                <a:cs typeface="Aptos Display" pitchFamily="34" charset="-120"/>
-              </a:rPr>
-              <a:t>Participant outputs for Day 5</a:t>
-            </a:r>
-            <a:endParaRPr lang="en-US" sz="2100" dirty="0"/>
-          </a:p>
-        </p:txBody>
-      </p:sp>
-      <p:sp>
-        <p:nvSpPr>
-          <p:cNvPr id="6" name="Text 4"/>
-          <p:cNvSpPr/>
-          <p:nvPr/>
-        </p:nvSpPr>
-        <p:spPr>
-          <a:xfrm>
-            <a:off x="411480" y="1170432"/>
-            <a:ext cx="11155680" cy="274320"/>
-          </a:xfrm>
-          <a:prstGeom prst="rect">
-            <a:avLst/>
-          </a:prstGeom>
-          <a:noFill/>
-          <a:ln/>
-        </p:spPr>
-        <p:txBody>
-          <a:bodyPr wrap="square" lIns="0" tIns="0" rIns="0" bIns="0" rtlCol="0" anchor="ctr">
-            <a:normAutofit/>
-          </a:bodyPr>
-          <a:lstStyle/>
-          <a:p>
-            <a:pPr marL="0" indent="0">
-              <a:buNone/>
-            </a:pPr>
-            <a:r>
-              <a:rPr lang="en-US" sz="1050" dirty="0">
-                <a:solidFill>
-                  <a:srgbClr val="666666"/>
-                </a:solidFill>
-              </a:rPr>
-              <a:t>The goal is not only to hear about AI workflows, but to leave with reusable structures and prompts.</a:t>
-            </a:r>
-            <a:endParaRPr lang="en-US" sz="1050" dirty="0"/>
-          </a:p>
-        </p:txBody>
-      </p:sp>
-      <p:sp>
-        <p:nvSpPr>
-          <p:cNvPr id="7" name="Shape 5"/>
-          <p:cNvSpPr/>
-          <p:nvPr/>
-        </p:nvSpPr>
-        <p:spPr>
-          <a:xfrm>
-            <a:off x="411480" y="1572768"/>
-            <a:ext cx="2926080" cy="22860"/>
-          </a:xfrm>
-          <a:prstGeom prst="rect">
-            <a:avLst/>
-          </a:prstGeom>
-          <a:solidFill>
-            <a:srgbClr val="CC0000"/>
-          </a:solidFill>
-          <a:ln w="12700">
-            <a:solidFill>
-              <a:srgbClr val="CC0000"/>
-            </a:solidFill>
-            <a:prstDash val="solid"/>
-          </a:ln>
-        </p:spPr>
-        <p:txBody>
-          <a:bodyPr/>
-          <a:lstStyle/>
-          <a:p>
-            <a:endParaRPr lang="en-US"/>
-          </a:p>
-        </p:txBody>
-      </p:sp>
-      <p:sp>
-        <p:nvSpPr>
-          <p:cNvPr id="8" name="Shape 6"/>
-          <p:cNvSpPr/>
-          <p:nvPr/>
-        </p:nvSpPr>
-        <p:spPr>
-          <a:xfrm>
-            <a:off x="685800" y="1828800"/>
-            <a:ext cx="3200400" cy="914400"/>
-          </a:xfrm>
-          <a:prstGeom prst="roundRect">
-            <a:avLst>
-              <a:gd name="adj" fmla="val 8000"/>
-            </a:avLst>
-          </a:prstGeom>
-          <a:solidFill>
-            <a:srgbClr val="FFF8F8"/>
-          </a:solidFill>
-          <a:ln w="12700">
-            <a:solidFill>
-              <a:srgbClr val="E0E0E0">
-                <a:alpha val="90000"/>
-              </a:srgbClr>
-            </a:solidFill>
-            <a:prstDash val="solid"/>
-          </a:ln>
-        </p:spPr>
-        <p:txBody>
-          <a:bodyPr/>
-          <a:lstStyle/>
-          <a:p>
-            <a:endParaRPr lang="en-US"/>
-          </a:p>
-        </p:txBody>
-      </p:sp>
-      <p:sp>
-        <p:nvSpPr>
-          <p:cNvPr id="9" name="Text 7"/>
-          <p:cNvSpPr/>
-          <p:nvPr/>
-        </p:nvSpPr>
-        <p:spPr>
-          <a:xfrm>
-            <a:off x="832104" y="1947672"/>
-            <a:ext cx="2907792" cy="228600"/>
-          </a:xfrm>
-          <a:prstGeom prst="rect">
-            <a:avLst/>
-          </a:prstGeom>
-          <a:noFill/>
-          <a:ln/>
-        </p:spPr>
-        <p:txBody>
-          <a:bodyPr wrap="square" lIns="0" tIns="0" rIns="0" bIns="0" rtlCol="0" anchor="ctr">
-            <a:normAutofit/>
-          </a:bodyPr>
-          <a:lstStyle/>
-          <a:p>
-            <a:pPr marL="0" indent="0">
-              <a:buNone/>
-            </a:pPr>
-            <a:r>
-              <a:rPr lang="en-US" sz="850" b="1" dirty="0">
-                <a:solidFill>
-                  <a:srgbClr val="CC0000"/>
-                </a:solidFill>
-              </a:rPr>
-              <a:t>AI evidence package</a:t>
-            </a:r>
-            <a:endParaRPr lang="en-US" sz="850" dirty="0"/>
-          </a:p>
-        </p:txBody>
-      </p:sp>
-      <p:sp>
-        <p:nvSpPr>
-          <p:cNvPr id="10" name="Text 8"/>
-          <p:cNvSpPr/>
-          <p:nvPr/>
-        </p:nvSpPr>
-        <p:spPr>
-          <a:xfrm>
-            <a:off x="832104" y="2240280"/>
-            <a:ext cx="2907792" cy="411480"/>
-          </a:xfrm>
-          <a:prstGeom prst="rect">
-            <a:avLst/>
-          </a:prstGeom>
-          <a:noFill/>
-          <a:ln/>
-        </p:spPr>
-        <p:txBody>
-          <a:bodyPr wrap="square" lIns="254" tIns="254" rIns="254" bIns="254" rtlCol="0" anchor="ctr">
-            <a:normAutofit/>
-          </a:bodyPr>
-          <a:lstStyle/>
-          <a:p>
-            <a:pPr marL="0" indent="0">
-              <a:buNone/>
-            </a:pPr>
-            <a:r>
-              <a:rPr lang="en-US" sz="1000" dirty="0">
-                <a:solidFill>
-                  <a:srgbClr val="222222"/>
-                </a:solidFill>
-              </a:rPr>
-              <a:t>Problem, dataset, baseline, model result, limitations, and claim boundaries.</a:t>
-            </a:r>
-            <a:endParaRPr lang="en-US" sz="1000" dirty="0"/>
-          </a:p>
-        </p:txBody>
-      </p:sp>
-      <p:sp>
-        <p:nvSpPr>
-          <p:cNvPr id="11" name="Shape 9"/>
-          <p:cNvSpPr/>
-          <p:nvPr/>
-        </p:nvSpPr>
-        <p:spPr>
-          <a:xfrm>
-            <a:off x="4480560" y="1828800"/>
-            <a:ext cx="3200400" cy="914400"/>
-          </a:xfrm>
-          <a:prstGeom prst="roundRect">
-            <a:avLst>
-              <a:gd name="adj" fmla="val 8000"/>
-            </a:avLst>
-          </a:prstGeom>
-          <a:solidFill>
-            <a:srgbClr val="E9F1FB"/>
-          </a:solidFill>
-          <a:ln w="12700">
-            <a:solidFill>
-              <a:srgbClr val="E0E0E0">
-                <a:alpha val="90000"/>
-              </a:srgbClr>
-            </a:solidFill>
-            <a:prstDash val="solid"/>
-          </a:ln>
-        </p:spPr>
-        <p:txBody>
-          <a:bodyPr/>
-          <a:lstStyle/>
-          <a:p>
-            <a:endParaRPr lang="en-US"/>
-          </a:p>
-        </p:txBody>
-      </p:sp>
-      <p:sp>
-        <p:nvSpPr>
-          <p:cNvPr id="12" name="Text 10"/>
-          <p:cNvSpPr/>
-          <p:nvPr/>
-        </p:nvSpPr>
-        <p:spPr>
-          <a:xfrm>
-            <a:off x="4626864" y="1947672"/>
-            <a:ext cx="2907792" cy="228600"/>
-          </a:xfrm>
-          <a:prstGeom prst="rect">
-            <a:avLst/>
-          </a:prstGeom>
-          <a:noFill/>
-          <a:ln/>
-        </p:spPr>
-        <p:txBody>
-          <a:bodyPr wrap="square" lIns="0" tIns="0" rIns="0" bIns="0" rtlCol="0" anchor="ctr">
-            <a:normAutofit/>
-          </a:bodyPr>
-          <a:lstStyle/>
-          <a:p>
-            <a:pPr marL="0" indent="0">
-              <a:buNone/>
-            </a:pPr>
-            <a:r>
-              <a:rPr lang="en-US" sz="850" b="1" dirty="0">
-                <a:solidFill>
-                  <a:srgbClr val="222222"/>
-                </a:solidFill>
-              </a:rPr>
-              <a:t>Prompt-chain recipe</a:t>
-            </a:r>
-            <a:endParaRPr lang="en-US" sz="850" dirty="0"/>
-          </a:p>
-        </p:txBody>
-      </p:sp>
-      <p:sp>
-        <p:nvSpPr>
-          <p:cNvPr id="13" name="Text 11"/>
-          <p:cNvSpPr/>
-          <p:nvPr/>
-        </p:nvSpPr>
-        <p:spPr>
-          <a:xfrm>
-            <a:off x="4626864" y="2240280"/>
-            <a:ext cx="2907792" cy="411480"/>
-          </a:xfrm>
-          <a:prstGeom prst="rect">
-            <a:avLst/>
-          </a:prstGeom>
-          <a:noFill/>
-          <a:ln/>
-        </p:spPr>
-        <p:txBody>
-          <a:bodyPr wrap="square" lIns="254" tIns="254" rIns="254" bIns="254" rtlCol="0" anchor="ctr">
-            <a:normAutofit/>
-          </a:bodyPr>
-          <a:lstStyle/>
-          <a:p>
-            <a:pPr marL="0" indent="0">
-              <a:buNone/>
-            </a:pPr>
-            <a:r>
-              <a:rPr lang="en-US" sz="1000" dirty="0">
-                <a:solidFill>
-                  <a:srgbClr val="222222"/>
-                </a:solidFill>
-              </a:rPr>
-              <a:t>A reusable seven-step sequence for generating a notebook scaffold.</a:t>
-            </a:r>
-            <a:endParaRPr lang="en-US" sz="1000" dirty="0"/>
-          </a:p>
-        </p:txBody>
-      </p:sp>
-      <p:sp>
-        <p:nvSpPr>
-          <p:cNvPr id="14" name="Shape 12"/>
-          <p:cNvSpPr/>
-          <p:nvPr/>
-        </p:nvSpPr>
-        <p:spPr>
-          <a:xfrm>
-            <a:off x="8275320" y="1828800"/>
-            <a:ext cx="3200400" cy="914400"/>
-          </a:xfrm>
-          <a:prstGeom prst="roundRect">
-            <a:avLst>
-              <a:gd name="adj" fmla="val 8000"/>
-            </a:avLst>
-          </a:prstGeom>
-          <a:solidFill>
-            <a:srgbClr val="E8F5E9"/>
-          </a:solidFill>
-          <a:ln w="12700">
-            <a:solidFill>
-              <a:srgbClr val="E0E0E0">
-                <a:alpha val="90000"/>
-              </a:srgbClr>
-            </a:solidFill>
-            <a:prstDash val="solid"/>
-          </a:ln>
-        </p:spPr>
-        <p:txBody>
-          <a:bodyPr/>
-          <a:lstStyle/>
-          <a:p>
-            <a:endParaRPr lang="en-US"/>
-          </a:p>
-        </p:txBody>
-      </p:sp>
-      <p:sp>
-        <p:nvSpPr>
-          <p:cNvPr id="15" name="Text 13"/>
-          <p:cNvSpPr/>
-          <p:nvPr/>
-        </p:nvSpPr>
-        <p:spPr>
-          <a:xfrm>
-            <a:off x="8421624" y="1947672"/>
-            <a:ext cx="2907792" cy="228600"/>
-          </a:xfrm>
-          <a:prstGeom prst="rect">
-            <a:avLst/>
-          </a:prstGeom>
-          <a:noFill/>
-          <a:ln/>
-        </p:spPr>
-        <p:txBody>
-          <a:bodyPr wrap="square" lIns="0" tIns="0" rIns="0" bIns="0" rtlCol="0" anchor="ctr">
-            <a:normAutofit/>
-          </a:bodyPr>
-          <a:lstStyle/>
-          <a:p>
-            <a:pPr marL="0" indent="0">
-              <a:buNone/>
-            </a:pPr>
-            <a:r>
-              <a:rPr lang="en-US" sz="850" b="1" dirty="0">
-                <a:solidFill>
-                  <a:srgbClr val="222222"/>
-                </a:solidFill>
-              </a:rPr>
-              <a:t>AI audit checklist</a:t>
-            </a:r>
-            <a:endParaRPr lang="en-US" sz="850" dirty="0"/>
-          </a:p>
-        </p:txBody>
-      </p:sp>
-      <p:sp>
-        <p:nvSpPr>
-          <p:cNvPr id="16" name="Text 14"/>
-          <p:cNvSpPr/>
-          <p:nvPr/>
-        </p:nvSpPr>
-        <p:spPr>
-          <a:xfrm>
-            <a:off x="8421624" y="2240280"/>
-            <a:ext cx="2907792" cy="411480"/>
-          </a:xfrm>
-          <a:prstGeom prst="rect">
-            <a:avLst/>
-          </a:prstGeom>
-          <a:noFill/>
-          <a:ln/>
-        </p:spPr>
-        <p:txBody>
-          <a:bodyPr wrap="square" lIns="254" tIns="254" rIns="254" bIns="254" rtlCol="0" anchor="ctr">
-            <a:normAutofit/>
-          </a:bodyPr>
-          <a:lstStyle/>
-          <a:p>
-            <a:pPr marL="0" indent="0">
-              <a:buNone/>
-            </a:pPr>
-            <a:r>
-              <a:rPr lang="en-US" sz="1000" dirty="0">
-                <a:solidFill>
-                  <a:srgbClr val="222222"/>
-                </a:solidFill>
-              </a:rPr>
-              <a:t>Criteria for rejecting or revising AI-generated code and explanations.</a:t>
-            </a:r>
-            <a:endParaRPr lang="en-US" sz="1000" dirty="0"/>
-          </a:p>
-        </p:txBody>
-      </p:sp>
-      <p:sp>
-        <p:nvSpPr>
-          <p:cNvPr id="17" name="Shape 15"/>
-          <p:cNvSpPr/>
-          <p:nvPr/>
-        </p:nvSpPr>
-        <p:spPr>
-          <a:xfrm>
-            <a:off x="685800" y="3246120"/>
-            <a:ext cx="3200400" cy="914400"/>
-          </a:xfrm>
-          <a:prstGeom prst="roundRect">
-            <a:avLst>
-              <a:gd name="adj" fmla="val 8000"/>
-            </a:avLst>
-          </a:prstGeom>
-          <a:solidFill>
-            <a:srgbClr val="FFF8E1"/>
-          </a:solidFill>
-          <a:ln w="12700">
-            <a:solidFill>
-              <a:srgbClr val="E0E0E0">
-                <a:alpha val="90000"/>
-              </a:srgbClr>
-            </a:solidFill>
-            <a:prstDash val="solid"/>
-          </a:ln>
-        </p:spPr>
-        <p:txBody>
-          <a:bodyPr/>
-          <a:lstStyle/>
-          <a:p>
-            <a:endParaRPr lang="en-US"/>
-          </a:p>
-        </p:txBody>
-      </p:sp>
-      <p:sp>
-        <p:nvSpPr>
-          <p:cNvPr id="18" name="Text 16"/>
-          <p:cNvSpPr/>
-          <p:nvPr/>
-        </p:nvSpPr>
-        <p:spPr>
-          <a:xfrm>
-            <a:off x="832104" y="3364992"/>
-            <a:ext cx="2907792" cy="228600"/>
-          </a:xfrm>
-          <a:prstGeom prst="rect">
-            <a:avLst/>
-          </a:prstGeom>
-          <a:noFill/>
-          <a:ln/>
-        </p:spPr>
-        <p:txBody>
-          <a:bodyPr wrap="square" lIns="0" tIns="0" rIns="0" bIns="0" rtlCol="0" anchor="ctr">
-            <a:normAutofit/>
-          </a:bodyPr>
-          <a:lstStyle/>
-          <a:p>
-            <a:pPr marL="0" indent="0">
-              <a:buNone/>
-            </a:pPr>
-            <a:r>
-              <a:rPr lang="en-US" sz="850" b="1" dirty="0">
-                <a:solidFill>
-                  <a:srgbClr val="222222"/>
-                </a:solidFill>
-              </a:rPr>
-              <a:t>Worked example notes</a:t>
-            </a:r>
-            <a:endParaRPr lang="en-US" sz="850" dirty="0"/>
-          </a:p>
-        </p:txBody>
-      </p:sp>
-      <p:sp>
-        <p:nvSpPr>
-          <p:cNvPr id="19" name="Text 17"/>
-          <p:cNvSpPr/>
-          <p:nvPr/>
-        </p:nvSpPr>
-        <p:spPr>
-          <a:xfrm>
-            <a:off x="832104" y="3657600"/>
-            <a:ext cx="2907792" cy="411480"/>
-          </a:xfrm>
-          <a:prstGeom prst="rect">
-            <a:avLst/>
-          </a:prstGeom>
-          <a:noFill/>
-          <a:ln/>
-        </p:spPr>
-        <p:txBody>
-          <a:bodyPr wrap="square" lIns="254" tIns="254" rIns="254" bIns="254" rtlCol="0" anchor="ctr">
-            <a:normAutofit/>
-          </a:bodyPr>
-          <a:lstStyle/>
-          <a:p>
-            <a:pPr marL="0" indent="0">
-              <a:buNone/>
-            </a:pPr>
-            <a:r>
-              <a:rPr lang="en-US" sz="1000" dirty="0">
-                <a:solidFill>
-                  <a:srgbClr val="222222"/>
-                </a:solidFill>
-              </a:rPr>
-              <a:t>Defect-prediction workflow from dataset to logistic regression and model card.</a:t>
-            </a:r>
-            <a:endParaRPr lang="en-US" sz="1000" dirty="0"/>
-          </a:p>
-        </p:txBody>
-      </p:sp>
-      <p:sp>
-        <p:nvSpPr>
-          <p:cNvPr id="20" name="Shape 18"/>
-          <p:cNvSpPr/>
-          <p:nvPr/>
-        </p:nvSpPr>
-        <p:spPr>
-          <a:xfrm>
-            <a:off x="4480560" y="3246120"/>
-            <a:ext cx="3200400" cy="914400"/>
-          </a:xfrm>
-          <a:prstGeom prst="roundRect">
-            <a:avLst>
-              <a:gd name="adj" fmla="val 8000"/>
-            </a:avLst>
-          </a:prstGeom>
-          <a:solidFill>
-            <a:srgbClr val="F3E5F5"/>
-          </a:solidFill>
-          <a:ln w="12700">
-            <a:solidFill>
-              <a:srgbClr val="E0E0E0">
-                <a:alpha val="90000"/>
-              </a:srgbClr>
-            </a:solidFill>
-            <a:prstDash val="solid"/>
-          </a:ln>
-        </p:spPr>
-        <p:txBody>
-          <a:bodyPr/>
-          <a:lstStyle/>
-          <a:p>
-            <a:endParaRPr lang="en-US"/>
-          </a:p>
-        </p:txBody>
-      </p:sp>
-      <p:sp>
-        <p:nvSpPr>
-          <p:cNvPr id="21" name="Text 19"/>
-          <p:cNvSpPr/>
-          <p:nvPr/>
-        </p:nvSpPr>
-        <p:spPr>
-          <a:xfrm>
-            <a:off x="4626864" y="3364992"/>
-            <a:ext cx="2907792" cy="228600"/>
-          </a:xfrm>
-          <a:prstGeom prst="rect">
-            <a:avLst/>
-          </a:prstGeom>
-          <a:noFill/>
-          <a:ln/>
-        </p:spPr>
-        <p:txBody>
-          <a:bodyPr wrap="square" lIns="0" tIns="0" rIns="0" bIns="0" rtlCol="0" anchor="ctr">
-            <a:normAutofit/>
-          </a:bodyPr>
-          <a:lstStyle/>
-          <a:p>
-            <a:pPr marL="0" indent="0">
-              <a:buNone/>
-            </a:pPr>
-            <a:r>
-              <a:rPr lang="en-US" sz="850" b="1" dirty="0">
-                <a:solidFill>
-                  <a:srgbClr val="222222"/>
-                </a:solidFill>
-              </a:rPr>
-              <a:t>Implementation idea</a:t>
-            </a:r>
-            <a:endParaRPr lang="en-US" sz="850" dirty="0"/>
-          </a:p>
-        </p:txBody>
-      </p:sp>
-      <p:sp>
-        <p:nvSpPr>
-          <p:cNvPr id="22" name="Text 20"/>
-          <p:cNvSpPr/>
-          <p:nvPr/>
-        </p:nvSpPr>
-        <p:spPr>
-          <a:xfrm>
-            <a:off x="4626864" y="3657600"/>
-            <a:ext cx="2907792" cy="411480"/>
-          </a:xfrm>
-          <a:prstGeom prst="rect">
-            <a:avLst/>
-          </a:prstGeom>
-          <a:noFill/>
-          <a:ln/>
-        </p:spPr>
-        <p:txBody>
-          <a:bodyPr wrap="square" lIns="254" tIns="254" rIns="254" bIns="254" rtlCol="0" anchor="ctr">
-            <a:normAutofit/>
-          </a:bodyPr>
-          <a:lstStyle/>
-          <a:p>
-            <a:pPr marL="0" indent="0">
-              <a:buNone/>
-            </a:pPr>
-            <a:r>
-              <a:rPr lang="en-US" sz="1000" dirty="0">
-                <a:solidFill>
-                  <a:srgbClr val="222222"/>
-                </a:solidFill>
-              </a:rPr>
-              <a:t>A faculty-specific teaching, research, or lab workflow where AI could assist.</a:t>
-            </a:r>
-            <a:endParaRPr lang="en-US" sz="1000" dirty="0"/>
-          </a:p>
-        </p:txBody>
-      </p:sp>
-      <p:sp>
-        <p:nvSpPr>
-          <p:cNvPr id="23" name="Shape 21"/>
-          <p:cNvSpPr/>
-          <p:nvPr/>
-        </p:nvSpPr>
-        <p:spPr>
-          <a:xfrm>
-            <a:off x="8275320" y="3246120"/>
-            <a:ext cx="3200400" cy="914400"/>
-          </a:xfrm>
-          <a:prstGeom prst="roundRect">
-            <a:avLst>
-              <a:gd name="adj" fmla="val 8000"/>
-            </a:avLst>
-          </a:prstGeom>
-          <a:solidFill>
-            <a:srgbClr val="F5F5F5"/>
-          </a:solidFill>
-          <a:ln w="12700">
-            <a:solidFill>
-              <a:srgbClr val="E0E0E0">
-                <a:alpha val="90000"/>
-              </a:srgbClr>
-            </a:solidFill>
-            <a:prstDash val="solid"/>
-          </a:ln>
-        </p:spPr>
-        <p:txBody>
-          <a:bodyPr/>
-          <a:lstStyle/>
-          <a:p>
-            <a:endParaRPr lang="en-US"/>
-          </a:p>
-        </p:txBody>
-      </p:sp>
-      <p:sp>
-        <p:nvSpPr>
-          <p:cNvPr id="24" name="Text 22"/>
-          <p:cNvSpPr/>
-          <p:nvPr/>
-        </p:nvSpPr>
-        <p:spPr>
-          <a:xfrm>
-            <a:off x="8421624" y="3364992"/>
-            <a:ext cx="2907792" cy="228600"/>
-          </a:xfrm>
-          <a:prstGeom prst="rect">
-            <a:avLst/>
-          </a:prstGeom>
-          <a:noFill/>
-          <a:ln/>
-        </p:spPr>
-        <p:txBody>
-          <a:bodyPr wrap="square" lIns="0" tIns="0" rIns="0" bIns="0" rtlCol="0" anchor="ctr">
-            <a:normAutofit/>
-          </a:bodyPr>
-          <a:lstStyle/>
-          <a:p>
-            <a:pPr marL="0" indent="0">
-              <a:buNone/>
-            </a:pPr>
-            <a:r>
-              <a:rPr lang="en-US" sz="850" b="1" dirty="0">
-                <a:solidFill>
-                  <a:srgbClr val="222222"/>
-                </a:solidFill>
-              </a:rPr>
-              <a:t>Open questions</a:t>
-            </a:r>
-            <a:endParaRPr lang="en-US" sz="850" dirty="0"/>
-          </a:p>
-        </p:txBody>
-      </p:sp>
-      <p:sp>
-        <p:nvSpPr>
-          <p:cNvPr id="25" name="Text 23"/>
-          <p:cNvSpPr/>
-          <p:nvPr/>
-        </p:nvSpPr>
-        <p:spPr>
-          <a:xfrm>
-            <a:off x="8421624" y="3657600"/>
-            <a:ext cx="2907792" cy="411480"/>
-          </a:xfrm>
-          <a:prstGeom prst="rect">
-            <a:avLst/>
-          </a:prstGeom>
-          <a:noFill/>
-          <a:ln/>
-        </p:spPr>
-        <p:txBody>
-          <a:bodyPr wrap="square" lIns="254" tIns="254" rIns="254" bIns="254" rtlCol="0" anchor="ctr">
-            <a:normAutofit/>
-          </a:bodyPr>
-          <a:lstStyle/>
-          <a:p>
-            <a:pPr marL="0" indent="0">
-              <a:buNone/>
-            </a:pPr>
-            <a:r>
-              <a:rPr lang="en-US" sz="1000" dirty="0">
-                <a:solidFill>
-                  <a:srgbClr val="222222"/>
-                </a:solidFill>
-              </a:rPr>
-              <a:t>Technical, ethical, and organizational issues to address after the workshop.</a:t>
-            </a:r>
-            <a:endParaRPr lang="en-US" sz="1000" dirty="0"/>
-          </a:p>
-        </p:txBody>
-      </p:sp>
-      <p:sp>
-        <p:nvSpPr>
-          <p:cNvPr id="26" name="Text 24"/>
-          <p:cNvSpPr/>
-          <p:nvPr/>
-        </p:nvSpPr>
-        <p:spPr>
-          <a:xfrm>
-            <a:off x="914400" y="5257800"/>
-            <a:ext cx="10241280" cy="384048"/>
-          </a:xfrm>
-          <a:prstGeom prst="rect">
-            <a:avLst/>
-          </a:prstGeom>
-          <a:noFill/>
-          <a:ln/>
-        </p:spPr>
-        <p:txBody>
-          <a:bodyPr wrap="square" lIns="0" tIns="0" rIns="0" bIns="0" rtlCol="0" anchor="ctr"/>
-          <a:lstStyle/>
-          <a:p>
-            <a:pPr marL="0" indent="0" algn="ctr">
-              <a:buNone/>
-            </a:pPr>
-            <a:r>
-              <a:rPr lang="en-US" sz="1150" b="1" dirty="0">
-                <a:solidFill>
-                  <a:srgbClr val="222222"/>
-                </a:solidFill>
-              </a:rPr>
-              <a:t>These outputs are intentionally lightweight: they can become a course example, a research planning artifact, or a prototype workflow design.</a:t>
-            </a:r>
-            <a:endParaRPr lang="en-US" sz="1150" dirty="0"/>
-          </a:p>
-        </p:txBody>
-      </p:sp>
-      <p:sp>
-        <p:nvSpPr>
-          <p:cNvPr id="27" name="Text 25"/>
-          <p:cNvSpPr/>
-          <p:nvPr/>
-        </p:nvSpPr>
-        <p:spPr>
-          <a:xfrm>
-            <a:off x="11567160" y="6510528"/>
-            <a:ext cx="228600" cy="137160"/>
-          </a:xfrm>
-          <a:prstGeom prst="rect">
-            <a:avLst/>
-          </a:prstGeom>
-          <a:noFill/>
-          <a:ln/>
-        </p:spPr>
-        <p:txBody>
-          <a:bodyPr wrap="square" lIns="0" tIns="0" rIns="0" bIns="0" rtlCol="0" anchor="ctr"/>
-          <a:lstStyle/>
-          <a:p>
-            <a:pPr marL="0" indent="0" algn="r">
-              <a:buNone/>
-            </a:pPr>
-            <a:r>
-              <a:rPr lang="en-US" sz="550" dirty="0">
-                <a:solidFill>
-                  <a:srgbClr val="999999"/>
-                </a:solidFill>
-              </a:rPr>
-              <a:t>9</a:t>
             </a:r>
             <a:endParaRPr lang="en-US" sz="550" dirty="0"/>
           </a:p>

</xml_diff>